<commit_message>
Finalize coursework contracts, aggregate naming and submission evidence
</commit_message>
<xml_diff>
--- a/presentation/coursework-slides.pptx
+++ b/presentation/coursework-slides.pptx
@@ -3680,7 +3680,7 @@
               </a:defRPr>
             </a:pPr>
             <a:r>
-              <a:t>• The application saves Trip and passes the event to the handler in the same process; no broker is needed.</a:t>
+              <a:t>• Within one transaction, the application saves Trip and invokes the injected handler in-process. No broker is needed; nested calls share a reentrant lock.</a:t>
             </a:r>
           </a:p>
           <a:p>
@@ -3712,7 +3712,7 @@
               </a:defRPr>
             </a:pPr>
             <a:r>
-              <a:t>• The handler stores the returned root; listings hide it. It returns 'withdrawn' to the booking DTO.</a:t>
+              <a:t>• The handler stores the returned root; listings hide it. The DTO carries AdvertisementStatus.WITHDRAWN; the view formats it for users.</a:t>
             </a:r>
           </a:p>
           <a:p>
@@ -3728,7 +3728,7 @@
               </a:defRPr>
             </a:pPr>
             <a:r>
-              <a:t>• Repeated delivery: B rejects withdrawal; the handler returns 'rejected: advertisement already withdrawn'. State is unchanged. Missing B also returns a rejection.</a:t>
+              <a:t>• Repeated delivery returns REJECTED / ALREADY_WITHDRAWN without state changes. Missing B returns REJECTED / MISSING; storage exceptions propagate and trigger rollback.</a:t>
             </a:r>
           </a:p>
         </p:txBody>
@@ -4008,7 +4008,7 @@
               </a:defRPr>
             </a:pPr>
             <a:r>
-              <a:t>• T2 / BR2: booking ID stored on the identified Trip; availability falls from 2 to 1.</a:t>
+              <a:t>• T2 / BR2: saved booking state, detached reads/writes, stable entity equality/hash, and read-only booking collection.</a:t>
             </a:r>
           </a:p>
           <a:p>
@@ -4024,7 +4024,7 @@
               </a:defRPr>
             </a:pPr>
             <a:r>
-              <a:t>• T3 / BR3: seat equal to capacity accepted; duplicate and capacity + 1 rejected without extra bookings.</a:t>
+              <a:t>• T3 / BR3: capacity boundary, duplicate/range/name rejection, and concurrent same-seat booking with one winner.</a:t>
             </a:r>
           </a:p>
           <a:p>
@@ -4040,7 +4040,7 @@
               </a:defRPr>
             </a:pPr>
             <a:r>
-              <a:t>• T4 / BR4: same bus/time rejected before storage; different bus/time accepted.</a:t>
+              <a:t>• T4 / BR4: bus/time conflict, another bus accepted, concurrent scheduling with one winner and no orphan advertisement.</a:t>
             </a:r>
           </a:p>
           <a:p>
@@ -4056,7 +4056,7 @@
               </a:defRPr>
             </a:pPr>
             <a:r>
-              <a:t>• T5 / BR5: no event before final seat; final booking returns TripFullyBooked with the trip identity.</a:t>
+              <a:t>• T5 / BR5: final-seat event; substitute updater/handler implementations work through protocols without inheritance.</a:t>
             </a:r>
           </a:p>
           <a:p>
@@ -4072,7 +4072,7 @@
               </a:defRPr>
             </a:pPr>
             <a:r>
-              <a:t>• T6 / BR6: missing Trip and duplicate trip number rejected; existing state unchanged.</a:t>
+              <a:t>• T6 / BR6: lookup/duplicate rejection; shared contracts and complete booking flow run against two repository adapters.</a:t>
             </a:r>
           </a:p>
           <a:p>
@@ -4088,7 +4088,7 @@
               </a:defRPr>
             </a:pPr>
             <a:r>
-              <a:t>• T7: full BookSeat use case returns 'withdrawn'; B is inactive/zero and absent from available listings.</a:t>
+              <a:t>• T7: concurrent distinct-seat bookings lose no updates; B withdraws once. Console controller/view flow also passes.</a:t>
             </a:r>
           </a:p>
           <a:p>
@@ -4104,7 +4104,7 @@
               </a:defRPr>
             </a:pPr>
             <a:r>
-              <a:t>• T8: repeated follow-up rejected; both final aggregate states and listing stay unchanged. Actual suite result: 8 tests, OK.</a:t>
+              <a:t>• T8: fresh persisted state after repeated rejection; missing B; rollback after Trip/B writes and scheduling failure. Eight scenarios, OK.</a:t>
             </a:r>
           </a:p>
         </p:txBody>
@@ -4329,7 +4329,7 @@
               </a:defRPr>
             </a:pPr>
             <a:r>
-              <a:t>T4 · captured during this revision</a:t>
+              <a:t>T2 isolation regression · evidence retained</a:t>
             </a:r>
           </a:p>
         </p:txBody>
@@ -4360,95 +4360,95 @@
               <a:spcAft>
                 <a:spcPts val="1000"/>
               </a:spcAft>
-              <a:defRPr sz="1800">
-                <a:solidFill>
-                  <a:srgbClr val="182B3B"/>
-                </a:solidFill>
-                <a:latin typeface="Aptos"/>
-              </a:defRPr>
-            </a:pPr>
-            <a:r>
-              <a:t>• RED: wrote T4 before the scheduling policy existed and ran it against the original scheduling behaviour (imports repaired).</a:t>
-            </a:r>
-          </a:p>
-          <a:p>
-            <a:pPr>
-              <a:spcAft>
-                <a:spcPts val="1000"/>
-              </a:spcAft>
-              <a:defRPr sz="1800">
-                <a:solidFill>
-                  <a:srgbClr val="182B3B"/>
-                </a:solidFill>
-                <a:latin typeface="Aptos"/>
-              </a:defRPr>
-            </a:pPr>
-            <a:r>
-              <a:t>• Actual failure: AssertionError: ValueError not raised. Evidence: evidence/tdd-red.txt (one test, one failure).</a:t>
-            </a:r>
-          </a:p>
-          <a:p>
-            <a:pPr>
-              <a:spcAft>
-                <a:spcPts val="1000"/>
-              </a:spcAft>
-              <a:defRPr sz="1800">
-                <a:solidFill>
-                  <a:srgbClr val="182B3B"/>
-                </a:solidFill>
-                <a:latin typeface="Aptos"/>
-              </a:defRPr>
-            </a:pPr>
-            <a:r>
-              <a:t>• IMPLEMENT: added BusSchedulingPolicy.ensure_available and invoked it before CreateTripService stores a Trip.</a:t>
-            </a:r>
-          </a:p>
-          <a:p>
-            <a:pPr>
-              <a:spcAft>
-                <a:spcPts val="1000"/>
-              </a:spcAft>
-              <a:defRPr sz="1800">
-                <a:solidFill>
-                  <a:srgbClr val="182B3B"/>
-                </a:solidFill>
-                <a:latin typeface="Aptos"/>
-              </a:defRPr>
-            </a:pPr>
-            <a:r>
-              <a:t>• GREEN: reran the same T4 unchanged; it passed. Evidence: evidence/tdd-green.txt.</a:t>
-            </a:r>
-          </a:p>
-          <a:p>
-            <a:pPr>
-              <a:spcAft>
-                <a:spcPts val="1000"/>
-              </a:spcAft>
-              <a:defRPr sz="1800">
-                <a:solidFill>
-                  <a:srgbClr val="182B3B"/>
-                </a:solidFill>
-                <a:latin typeface="Aptos"/>
-              </a:defRPr>
-            </a:pPr>
-            <a:r>
-              <a:t>• REFACTOR / REGRESSION: final complete suite contains exactly eight tests and passes. Evidence: evidence/test-results.txt.</a:t>
-            </a:r>
-          </a:p>
-          <a:p>
-            <a:pPr>
-              <a:spcAft>
-                <a:spcPts val="1000"/>
-              </a:spcAft>
-              <a:defRPr sz="1800">
-                <a:solidFill>
-                  <a:srgbClr val="182B3B"/>
-                </a:solidFill>
-                <a:latin typeface="Aptos"/>
-              </a:defRPr>
-            </a:pPr>
-            <a:r>
-              <a:t>• Inspect evidence/tdd-change.diff for the relevant change. This documents the new BR4 cycle, not the original project's development history.</a:t>
+              <a:defRPr sz="1600">
+                <a:solidFill>
+                  <a:srgbClr val="182B3B"/>
+                </a:solidFill>
+                <a:latin typeface="Aptos"/>
+              </a:defRPr>
+            </a:pPr>
+            <a:r>
+              <a:t>• RED: added an assertion that mutating a retrieved Trip must leave stored state unchanged until save. The existing adapter failed: AssertionError: 0 != 1.</a:t>
+            </a:r>
+          </a:p>
+          <a:p>
+            <a:pPr>
+              <a:spcAft>
+                <a:spcPts val="1000"/>
+              </a:spcAft>
+              <a:defRPr sz="1600">
+                <a:solidFill>
+                  <a:srgbClr val="182B3B"/>
+                </a:solidFill>
+                <a:latin typeface="Aptos"/>
+              </a:defRPr>
+            </a:pPr>
+            <a:r>
+              <a:t>• Evidence: evidence/isolation-red.txt records the actual failing run before the fix.</a:t>
+            </a:r>
+          </a:p>
+          <a:p>
+            <a:pPr>
+              <a:spcAft>
+                <a:spcPts val="1000"/>
+              </a:spcAft>
+              <a:defRPr sz="1600">
+                <a:solidFill>
+                  <a:srgbClr val="182B3B"/>
+                </a:solidFill>
+                <a:latin typeface="Aptos"/>
+              </a:defRPr>
+            </a:pPr>
+            <a:r>
+              <a:t>• IMPLEMENT: detach Trip roots on add/read/save; inject a UnitOfWork to serialize workflows and roll back exceptions.</a:t>
+            </a:r>
+          </a:p>
+          <a:p>
+            <a:pPr>
+              <a:spcAft>
+                <a:spcPts val="1000"/>
+              </a:spcAft>
+              <a:defRPr sz="1600">
+                <a:solidFill>
+                  <a:srgbClr val="182B3B"/>
+                </a:solidFill>
+                <a:latin typeface="Aptos"/>
+              </a:defRPr>
+            </a:pPr>
+            <a:r>
+              <a:t>• GREEN: the T2 isolation assertion passes in the revised scenario. Evidence: evidence/isolation-green.txt; tests were expanded further after the first failure.</a:t>
+            </a:r>
+          </a:p>
+          <a:p>
+            <a:pPr>
+              <a:spcAft>
+                <a:spcPts val="1000"/>
+              </a:spcAft>
+              <a:defRPr sz="1600">
+                <a:solidFill>
+                  <a:srgbClr val="182B3B"/>
+                </a:solidFill>
+                <a:latin typeface="Aptos"/>
+              </a:defRPr>
+            </a:pPr>
+            <a:r>
+              <a:t>• REGRESSION: all eight scenarios pass, including concurrency, storage failures, adapter substitution, and controller/view behaviour.</a:t>
+            </a:r>
+          </a:p>
+          <a:p>
+            <a:pPr>
+              <a:spcAft>
+                <a:spcPts val="1000"/>
+              </a:spcAft>
+              <a:defRPr sz="1600">
+                <a:solidFill>
+                  <a:srgbClr val="182B3B"/>
+                </a:solidFill>
+                <a:latin typeface="Aptos"/>
+              </a:defRPr>
+            </a:pPr>
+            <a:r>
+              <a:t>• The earlier BR4 TDD cycle remains in tdd-red.txt, tdd-green.txt, and tdd-change.diff. Both cycles are real revision evidence, not claims about the original development history.</a:t>
             </a:r>
           </a:p>
         </p:txBody>
@@ -4776,7 +4776,7 @@
               </a:defRPr>
             </a:pPr>
             <a:r>
-              <a:t>• Application saves Trip. Handler asks B to withdraw; B accepts and returns its inactive state, which is stored.</a:t>
+              <a:t>• Within the UnitOfWork, application saves Trip. Handler asks B to withdraw; B accepts and returns its inactive state, which is stored. Commit releases the lock.</a:t>
             </a:r>
           </a:p>
           <a:p>
@@ -5136,7 +5136,7 @@
               </a:defRPr>
             </a:pPr>
             <a:r>
-              <a:t>• AI assistance is disclosed in README. Each member must explain this tradeoff and trace the code independently.</a:t>
+              <a:t>• MVC separation: ConsoleApp parses/routes input; ConsoleView formats output; domain objects enforce rules. AI help is disclosed in README; each member must explain the design.</a:t>
             </a:r>
           </a:p>
         </p:txBody>
@@ -6528,7 +6528,23 @@
               </a:defRPr>
             </a:pPr>
             <a:r>
-              <a:t>• Frozen dataclasses prevent accidental field reassignment. Identity in this model is the explicit ID, not dataclass structural equality.</a:t>
+              <a:t>• Entities explicitly compare and hash by their ID, even when state differs. SeatNumber retains value equality. T2 checks stable identity across booking states.</a:t>
+            </a:r>
+          </a:p>
+          <a:p>
+            <a:pPr>
+              <a:spcAft>
+                <a:spcPts val="1000"/>
+              </a:spcAft>
+              <a:defRPr sz="1800">
+                <a:solidFill>
+                  <a:srgbClr val="182B3B"/>
+                </a:solidFill>
+                <a:latin typeface="Aptos"/>
+              </a:defRPr>
+            </a:pPr>
+            <a:r>
+              <a:t>• Frozen fields protect identity; Trip's private booking dictionary remains mutable through its methods. A read-only view protects callers.</a:t>
             </a:r>
           </a:p>
         </p:txBody>
@@ -7184,7 +7200,7 @@
               </a:defRPr>
             </a:pPr>
             <a:r>
-              <a:t>• CreateTripService loads existing trips and invokes the policy before adding the new Trip or advertisement.</a:t>
+              <a:t>• CreateTripService uses an indexed bus/time lookup, then invokes the injected SchedulingPolicy contract before storing the Trip and advertisement.</a:t>
             </a:r>
           </a:p>
           <a:p>
@@ -7472,7 +7488,7 @@
               <a:spcAft>
                 <a:spcPts val="1000"/>
               </a:spcAft>
-              <a:defRPr sz="1800">
+              <a:defRPr sz="1600">
                 <a:solidFill>
                   <a:srgbClr val="182B3B"/>
                 </a:solidFill>
@@ -7488,23 +7504,23 @@
               <a:spcAft>
                 <a:spcPts val="1000"/>
               </a:spcAft>
-              <a:defRPr sz="1800">
-                <a:solidFill>
-                  <a:srgbClr val="182B3B"/>
-                </a:solidFill>
-                <a:latin typeface="Aptos"/>
-              </a:defRPr>
-            </a:pPr>
-            <a:r>
-              <a:t>• Operations: add, find_by_number, list_all, save. Duplicate identities and saving unknown trips are rejected.</a:t>
-            </a:r>
-          </a:p>
-          <a:p>
-            <a:pPr>
-              <a:spcAft>
-                <a:spcPts val="1000"/>
-              </a:spcAft>
-              <a:defRPr sz="1800">
+              <a:defRPr sz="1600">
+                <a:solidFill>
+                  <a:srgbClr val="182B3B"/>
+                </a:solidFill>
+                <a:latin typeface="Aptos"/>
+              </a:defRPr>
+            </a:pPr>
+            <a:r>
+              <a:t>• Operations: add, find_by_number, find_departures, list_all, save. Reads and writes detach Trip state; changes are visible only after save.</a:t>
+            </a:r>
+          </a:p>
+          <a:p>
+            <a:pPr>
+              <a:spcAft>
+                <a:spcPts val="1000"/>
+              </a:spcAft>
+              <a:defRPr sz="1600">
                 <a:solidFill>
                   <a:srgbClr val="182B3B"/>
                 </a:solidFill>
@@ -7520,7 +7536,7 @@
               <a:spcAft>
                 <a:spcPts val="1000"/>
               </a:spcAft>
-              <a:defRPr sz="1800">
+              <a:defRPr sz="1600">
                 <a:solidFill>
                   <a:srgbClr val="182B3B"/>
                 </a:solidFill>
@@ -7536,7 +7552,7 @@
               <a:spcAft>
                 <a:spcPts val="1000"/>
               </a:spcAft>
-              <a:defRPr sz="1800">
+              <a:defRPr sz="1600">
                 <a:solidFill>
                   <a:srgbClr val="182B3B"/>
                 </a:solidFill>
@@ -7552,15 +7568,31 @@
               <a:spcAft>
                 <a:spcPts val="1000"/>
               </a:spcAft>
-              <a:defRPr sz="1800">
-                <a:solidFill>
-                  <a:srgbClr val="182B3B"/>
-                </a:solidFill>
-                <a:latin typeface="Aptos"/>
-              </a:defRPr>
-            </a:pPr>
-            <a:r>
-              <a:t>• Both implementations are process-local dictionaries. Restarting the console resets the data.</a:t>
+              <a:defRPr sz="1600">
+                <a:solidFill>
+                  <a:srgbClr val="182B3B"/>
+                </a:solidFill>
+                <a:latin typeface="Aptos"/>
+              </a:defRPr>
+            </a:pPr>
+            <a:r>
+              <a:t>• Both adapters share InMemoryStore and an injected UnitOfWork. Its reentrant lock serializes workflows; exceptions restore both roots and the departure index.</a:t>
+            </a:r>
+          </a:p>
+          <a:p>
+            <a:pPr>
+              <a:spcAft>
+                <a:spcPts val="1000"/>
+              </a:spcAft>
+              <a:defRPr sz="1600">
+                <a:solidFill>
+                  <a:srgbClr val="182B3B"/>
+                </a:solidFill>
+                <a:latin typeface="Aptos"/>
+              </a:defRPr>
+            </a:pPr>
+            <a:r>
+              <a:t>• T6 checks the same contract with a separate scan-based reference adapter. Storage remains process-local; snapshots cost O(n) and restart resets data.</a:t>
             </a:r>
           </a:p>
         </p:txBody>
@@ -8652,7 +8684,7 @@
               </a:defRPr>
             </a:pPr>
             <a:r>
-              <a:t>• Output: booking_id, trip_number, passenger_name, seat_number, available_seats, advertisement_outcome.</a:t>
+              <a:t>• Output: booking details, available_seats, and AdvertisementOutcome with enum status and optional enum rejection reason.</a:t>
             </a:r>
           </a:p>
           <a:p>
@@ -8684,7 +8716,7 @@
               </a:defRPr>
             </a:pPr>
             <a:r>
-              <a:t>• main.build_console_app constructs the two in-memory repositories and injects them into services/handler. Tests inject fresh repositories.</a:t>
+              <a:t>• main injects repositories, UnitOfWork, SchedulingPolicy, AdvertisementUpdater, and FullyBookedHandler. Application services import contracts rather than concrete collaborators.</a:t>
             </a:r>
           </a:p>
           <a:p>
@@ -8700,7 +8732,7 @@
               </a:defRPr>
             </a:pPr>
             <a:r>
-              <a:t>• A rejected follow-up is exposed explicitly. The booking remains committed; this example does not promise cross-aggregate transaction rollback.</a:t>
+              <a:t>• The transaction covers lookup through follow-up. Storage exceptions roll back both roots. A business rejection is a returned outcome; its valid booking remains committed.</a:t>
             </a:r>
           </a:p>
         </p:txBody>

</xml_diff>